<commit_message>
Focus the walkthrough on the Python ETL
</commit_message>
<xml_diff>
--- a/docs/CDM-pipeline-technical-walkthrough.pptx
+++ b/docs/CDM-pipeline-technical-walkthrough.pptx
@@ -505,7 +505,7 @@
           <a:p>
             <a:r>
               <a:rPr lang="en-US" dirty="0"/>
-              <a:t>Open with the result. Two supplied CSV files become Contact and SalesOrder, with a CDM model.json. The implementation covers all four tasks in the brief. It writes five contacts and four valid orders, quarantines the one orphan order, and serializes timestamps in exact UTC ISO 8601 format. Repository: https://github.com/ghostkernel-core/cdm-pipeline</a:t>
+              <a:t>Open with the ETL result. Python reads the two supplied CSV files, cleans and validates Contact and SalesOrder, writes the entity and quarantine CSVs, and generates model.json. It writes five contacts and four valid orders, quarantines the orphan order, and serializes timestamps in exact UTC ISO 8601 format.</a:t>
             </a:r>
             <a:endParaRPr lang="en-US" dirty="0"/>
           </a:p>
@@ -769,7 +769,7 @@
           <a:p>
             <a:r>
               <a:rPr lang="en-US" dirty="0"/>
-              <a:t>Close on reproducibility. The final entity data, quarantine rows, deterministic run log and model.json are committed. CI reruns the pipeline and fails if any output drifts. Forty-seven tests pass with 98.93 percent coverage; the workflow is green on Python 3.11 and 3.13. Repository: https://github.com/ghostkernel-core/cdm-pipeline</a:t>
+              <a:t>Close on how the Python ETL loads its outputs. write_entity serializes validated Pydantic records to Contact.csv and SalesOrder.csv. write_csv preserves rejected source rows with a reason. write_manifest builds model.json from those same entity models, including metadata, CDM data types, partition locations and the SalesOrder.customerid to Contact.contactid relationship. Because the outputs are overwritten deterministically, rerunning the ETL recreates the same package.</a:t>
             </a:r>
             <a:endParaRPr lang="en-US" dirty="0"/>
           </a:p>
@@ -1484,7 +1484,7 @@
         <p:spPr>
           <a:xfrm>
             <a:off x="594360" y="2560320"/>
-            <a:ext cx="5669280" cy="411480"/>
+            <a:ext cx="5806440" cy="411480"/>
           </a:xfrm>
           <a:prstGeom prst="rect">
             <a:avLst/>
@@ -1510,7 +1510,7 @@
                 <a:ea typeface="Calibri" pitchFamily="34" charset="-122"/>
                 <a:cs typeface="Calibri" pitchFamily="34" charset="-120"/>
               </a:rPr>
-              <a:t>One reproducible path: transform, store, describe and explain.</a:t>
+              <a:t>Python reads, cleans, validates and writes the complete CDM package.</a:t>
             </a:r>
             <a:endParaRPr lang="en-US" sz="1800" dirty="0"/>
           </a:p>
@@ -2295,7 +2295,7 @@
                 <a:ea typeface="Calibri" pitchFamily="34" charset="-122"/>
                 <a:cs typeface="Calibri" pitchFamily="34" charset="-120"/>
               </a:rPr>
-              <a:t>clean entity CSVs</a:t>
+              <a:t>read raw records</a:t>
             </a:r>
             <a:endParaRPr lang="en-US" sz="1200" dirty="0"/>
           </a:p>
@@ -2402,7 +2402,7 @@
                 <a:ea typeface="Calibri" pitchFamily="34" charset="-122"/>
                 <a:cs typeface="Calibri" pitchFamily="34" charset="-120"/>
               </a:rPr>
-              <a:t>required folder layout</a:t>
+              <a:t>clean + validate</a:t>
             </a:r>
             <a:endParaRPr lang="en-US" sz="1200" dirty="0"/>
           </a:p>
@@ -2509,7 +2509,7 @@
                 <a:ea typeface="Calibri" pitchFamily="34" charset="-122"/>
                 <a:cs typeface="Calibri" pitchFamily="34" charset="-120"/>
               </a:rPr>
-              <a:t>CDM model.json</a:t>
+              <a:t>write data + rejects</a:t>
             </a:r>
             <a:endParaRPr lang="en-US" sz="1200" dirty="0"/>
           </a:p>
@@ -2616,7 +2616,7 @@
                 <a:ea typeface="Calibri" pitchFamily="34" charset="-122"/>
                 <a:cs typeface="Calibri" pitchFamily="34" charset="-120"/>
               </a:rPr>
-              <a:t>mapping + ERD + storage</a:t>
+              <a:t>generate model.json</a:t>
             </a:r>
             <a:endParaRPr lang="en-US" sz="1200" dirty="0"/>
           </a:p>
@@ -2657,7 +2657,7 @@
                 <a:ea typeface="Calibri" pitchFamily="34" charset="-122"/>
                 <a:cs typeface="Calibri" pitchFamily="34" charset="-120"/>
               </a:rPr>
-              <a:t>github.com/ghostkernel-core/cdm-pipeline</a:t>
+              <a:t>Entry point: python -m src.main</a:t>
             </a:r>
             <a:endParaRPr lang="en-US" sz="1200" dirty="0"/>
           </a:p>
@@ -6244,7 +6244,7 @@
         <p:spPr>
           <a:xfrm>
             <a:off x="594360" y="475488"/>
-            <a:ext cx="1097280" cy="320040"/>
+            <a:ext cx="1444752" cy="320040"/>
           </a:xfrm>
           <a:prstGeom prst="roundRect">
             <a:avLst>
@@ -6271,7 +6271,7 @@
         <p:spPr>
           <a:xfrm>
             <a:off x="594360" y="475488"/>
-            <a:ext cx="1097280" cy="320040"/>
+            <a:ext cx="1444752" cy="320040"/>
           </a:xfrm>
           <a:prstGeom prst="rect">
             <a:avLst/>
@@ -6297,7 +6297,7 @@
                 <a:ea typeface="Calibri" pitchFamily="34" charset="-122"/>
                 <a:cs typeface="Calibri" pitchFamily="34" charset="-120"/>
               </a:rPr>
-              <a:t>DELIVERED</a:t>
+              <a:t>LOAD + DESCRIBE</a:t>
             </a:r>
             <a:endParaRPr lang="en-US" sz="1100" dirty="0"/>
           </a:p>
@@ -6312,7 +6312,7 @@
         <p:spPr>
           <a:xfrm>
             <a:off x="594360" y="1005840"/>
-            <a:ext cx="7589520" cy="566928"/>
+            <a:ext cx="8366760" cy="566928"/>
           </a:xfrm>
           <a:prstGeom prst="rect">
             <a:avLst/>
@@ -6338,7 +6338,7 @@
                 <a:ea typeface="Cambria" pitchFamily="34" charset="-122"/>
                 <a:cs typeface="Cambria" pitchFamily="34" charset="-120"/>
               </a:rPr>
-              <a:t>Self-describing, tested and reproducible</a:t>
+              <a:t>One run writes data, rejects and metadata</a:t>
             </a:r>
             <a:endParaRPr lang="en-US" sz="3000" dirty="0"/>
           </a:p>
@@ -6353,7 +6353,7 @@
         <p:spPr>
           <a:xfrm>
             <a:off x="621792" y="1682496"/>
-            <a:ext cx="6217920" cy="347472"/>
+            <a:ext cx="6766560" cy="347472"/>
           </a:xfrm>
           <a:prstGeom prst="rect">
             <a:avLst/>
@@ -6379,7 +6379,7 @@
                 <a:ea typeface="Calibri" pitchFamily="34" charset="-122"/>
                 <a:cs typeface="Calibri" pitchFamily="34" charset="-120"/>
               </a:rPr>
-              <a:t>A fresh CI run must reproduce every committed output.</a:t>
+              <a:t>The entity models keep CSV columns and model.json attributes aligned.</a:t>
             </a:r>
             <a:endParaRPr lang="en-US" sz="1600" dirty="0"/>
           </a:p>
@@ -6393,12 +6393,12 @@
         </p:nvSpPr>
         <p:spPr>
           <a:xfrm>
-            <a:off x="621792" y="2359152"/>
-            <a:ext cx="5532120" cy="3246120"/>
+            <a:off x="621792" y="2331720"/>
+            <a:ext cx="5166360" cy="3364992"/>
           </a:xfrm>
           <a:prstGeom prst="roundRect">
             <a:avLst>
-              <a:gd name="adj" fmla="val 2817"/>
+              <a:gd name="adj" fmla="val 2717"/>
             </a:avLst>
           </a:prstGeom>
           <a:solidFill>
@@ -6420,8 +6420,8 @@
         </p:nvSpPr>
         <p:spPr>
           <a:xfrm>
-            <a:off x="914400" y="2615184"/>
-            <a:ext cx="2057400" cy="320040"/>
+            <a:off x="914400" y="2596896"/>
+            <a:ext cx="2377440" cy="320040"/>
           </a:xfrm>
           <a:prstGeom prst="rect">
             <a:avLst/>
@@ -6447,7 +6447,7 @@
                 <a:ea typeface="Calibri" pitchFamily="34" charset="-122"/>
                 <a:cs typeface="Calibri" pitchFamily="34" charset="-120"/>
               </a:rPr>
-              <a:t>repository outputs</a:t>
+              <a:t>python -m src.main</a:t>
             </a:r>
             <a:endParaRPr lang="en-US" sz="1700" dirty="0"/>
           </a:p>
@@ -6461,7 +6461,7 @@
         </p:nvSpPr>
         <p:spPr>
           <a:xfrm>
-            <a:off x="978408" y="3154680"/>
+            <a:off x="978408" y="3136392"/>
             <a:ext cx="274320" cy="256032"/>
           </a:xfrm>
           <a:prstGeom prst="rect">
@@ -6502,8 +6502,8 @@
         </p:nvSpPr>
         <p:spPr>
           <a:xfrm>
-            <a:off x="1325880" y="3154680"/>
-            <a:ext cx="2103120" cy="256032"/>
+            <a:off x="1325880" y="3136392"/>
+            <a:ext cx="1920240" cy="256032"/>
           </a:xfrm>
           <a:prstGeom prst="rect">
             <a:avLst/>
@@ -6529,7 +6529,7 @@
                 <a:ea typeface="Calibri" pitchFamily="34" charset="-122"/>
                 <a:cs typeface="Calibri" pitchFamily="34" charset="-120"/>
               </a:rPr>
-              <a:t>cdm_lakehouse/</a:t>
+              <a:t>Contact.csv</a:t>
             </a:r>
             <a:endParaRPr lang="en-US" sz="1300" dirty="0"/>
           </a:p>
@@ -6543,8 +6543,8 @@
         </p:nvSpPr>
         <p:spPr>
           <a:xfrm>
-            <a:off x="3456432" y="3154680"/>
-            <a:ext cx="2331720" cy="256032"/>
+            <a:off x="3246120" y="3136392"/>
+            <a:ext cx="2176272" cy="256032"/>
           </a:xfrm>
           <a:prstGeom prst="rect">
             <a:avLst/>
@@ -6570,7 +6570,7 @@
                 <a:ea typeface="Calibri" pitchFamily="34" charset="-122"/>
                 <a:cs typeface="Calibri" pitchFamily="34" charset="-120"/>
               </a:rPr>
-              <a:t>Contact · SalesOrder · model.json</a:t>
+              <a:t>5 validated contacts</a:t>
             </a:r>
             <a:endParaRPr lang="en-US" sz="1200" dirty="0"/>
           </a:p>
@@ -6584,7 +6584,7 @@
         </p:nvSpPr>
         <p:spPr>
           <a:xfrm>
-            <a:off x="978408" y="3721608"/>
+            <a:off x="978408" y="3703320"/>
             <a:ext cx="274320" cy="256032"/>
           </a:xfrm>
           <a:prstGeom prst="rect">
@@ -6625,8 +6625,8 @@
         </p:nvSpPr>
         <p:spPr>
           <a:xfrm>
-            <a:off x="1325880" y="3721608"/>
-            <a:ext cx="2103120" cy="256032"/>
+            <a:off x="1325880" y="3703320"/>
+            <a:ext cx="1920240" cy="256032"/>
           </a:xfrm>
           <a:prstGeom prst="rect">
             <a:avLst/>
@@ -6652,7 +6652,7 @@
                 <a:ea typeface="Calibri" pitchFamily="34" charset="-122"/>
                 <a:cs typeface="Calibri" pitchFamily="34" charset="-120"/>
               </a:rPr>
-              <a:t>quarantine/</a:t>
+              <a:t>SalesOrder.csv</a:t>
             </a:r>
             <a:endParaRPr lang="en-US" sz="1300" dirty="0"/>
           </a:p>
@@ -6666,8 +6666,8 @@
         </p:nvSpPr>
         <p:spPr>
           <a:xfrm>
-            <a:off x="3456432" y="3721608"/>
-            <a:ext cx="2331720" cy="256032"/>
+            <a:off x="3246120" y="3703320"/>
+            <a:ext cx="2176272" cy="256032"/>
           </a:xfrm>
           <a:prstGeom prst="rect">
             <a:avLst/>
@@ -6693,7 +6693,7 @@
                 <a:ea typeface="Calibri" pitchFamily="34" charset="-122"/>
                 <a:cs typeface="Calibri" pitchFamily="34" charset="-120"/>
               </a:rPr>
-              <a:t>rejected rows + reasons</a:t>
+              <a:t>4 valid orders</a:t>
             </a:r>
             <a:endParaRPr lang="en-US" sz="1200" dirty="0"/>
           </a:p>
@@ -6707,7 +6707,7 @@
         </p:nvSpPr>
         <p:spPr>
           <a:xfrm>
-            <a:off x="978408" y="4288536"/>
+            <a:off x="978408" y="4270248"/>
             <a:ext cx="274320" cy="256032"/>
           </a:xfrm>
           <a:prstGeom prst="rect">
@@ -6748,8 +6748,8 @@
         </p:nvSpPr>
         <p:spPr>
           <a:xfrm>
-            <a:off x="1325880" y="4288536"/>
-            <a:ext cx="2103120" cy="256032"/>
+            <a:off x="1325880" y="4270248"/>
+            <a:ext cx="1920240" cy="256032"/>
           </a:xfrm>
           <a:prstGeom prst="rect">
             <a:avLst/>
@@ -6775,7 +6775,7 @@
                 <a:ea typeface="Calibri" pitchFamily="34" charset="-122"/>
                 <a:cs typeface="Calibri" pitchFamily="34" charset="-120"/>
               </a:rPr>
-              <a:t>logs/pipeline-run.log</a:t>
+              <a:t>quarantine/*.csv</a:t>
             </a:r>
             <a:endParaRPr lang="en-US" sz="1300" dirty="0"/>
           </a:p>
@@ -6789,8 +6789,8 @@
         </p:nvSpPr>
         <p:spPr>
           <a:xfrm>
-            <a:off x="3456432" y="4288536"/>
-            <a:ext cx="2331720" cy="256032"/>
+            <a:off x="3246120" y="4270248"/>
+            <a:ext cx="2176272" cy="256032"/>
           </a:xfrm>
           <a:prstGeom prst="rect">
             <a:avLst/>
@@ -6816,6 +6816,129 @@
                 <a:ea typeface="Calibri" pitchFamily="34" charset="-122"/>
                 <a:cs typeface="Calibri" pitchFamily="34" charset="-120"/>
               </a:rPr>
+              <a:t>raw rejected row + reason</a:t>
+            </a:r>
+            <a:endParaRPr lang="en-US" sz="1200" dirty="0"/>
+          </a:p>
+        </p:txBody>
+      </p:sp>
+      <p:sp>
+        <p:nvSpPr>
+          <p:cNvPr id="17" name="Text 15"/>
+          <p:cNvSpPr txBox="1"/>
+          <p:nvPr/>
+        </p:nvSpPr>
+        <p:spPr>
+          <a:xfrm>
+            <a:off x="978408" y="4837176"/>
+            <a:ext cx="274320" cy="256032"/>
+          </a:xfrm>
+          <a:prstGeom prst="rect">
+            <a:avLst/>
+          </a:prstGeom>
+          <a:noFill/>
+          <a:ln/>
+        </p:spPr>
+        <p:txBody>
+          <a:bodyPr wrap="square" lIns="0" tIns="0" rIns="0" bIns="0" rtlCol="0" anchor="ctr">
+            <a:normAutofit/>
+          </a:bodyPr>
+          <a:lstStyle/>
+          <a:p>
+            <a:pPr algn="l" indent="0" marL="0">
+              <a:buNone/>
+            </a:pPr>
+            <a:r>
+              <a:rPr lang="en-US" sz="1500" b="1" dirty="0">
+                <a:solidFill>
+                  <a:srgbClr val="F2C14E"/>
+                </a:solidFill>
+                <a:latin typeface="Calibri" pitchFamily="34" charset="0"/>
+                <a:ea typeface="Calibri" pitchFamily="34" charset="-122"/>
+                <a:cs typeface="Calibri" pitchFamily="34" charset="-120"/>
+              </a:rPr>
+              <a:t>↳</a:t>
+            </a:r>
+            <a:endParaRPr lang="en-US" sz="1500" dirty="0"/>
+          </a:p>
+        </p:txBody>
+      </p:sp>
+      <p:sp>
+        <p:nvSpPr>
+          <p:cNvPr id="18" name="Text 16"/>
+          <p:cNvSpPr txBox="1"/>
+          <p:nvPr/>
+        </p:nvSpPr>
+        <p:spPr>
+          <a:xfrm>
+            <a:off x="1325880" y="4837176"/>
+            <a:ext cx="1920240" cy="256032"/>
+          </a:xfrm>
+          <a:prstGeom prst="rect">
+            <a:avLst/>
+          </a:prstGeom>
+          <a:noFill/>
+          <a:ln/>
+        </p:spPr>
+        <p:txBody>
+          <a:bodyPr wrap="square" lIns="0" tIns="0" rIns="0" bIns="0" rtlCol="0" anchor="ctr">
+            <a:normAutofit/>
+          </a:bodyPr>
+          <a:lstStyle/>
+          <a:p>
+            <a:pPr algn="l" indent="0" marL="0">
+              <a:buNone/>
+            </a:pPr>
+            <a:r>
+              <a:rPr lang="en-US" sz="1300" b="1" dirty="0">
+                <a:solidFill>
+                  <a:srgbClr val="FFFFFF"/>
+                </a:solidFill>
+                <a:latin typeface="Calibri" pitchFamily="34" charset="0"/>
+                <a:ea typeface="Calibri" pitchFamily="34" charset="-122"/>
+                <a:cs typeface="Calibri" pitchFamily="34" charset="-120"/>
+              </a:rPr>
+              <a:t>pipeline-run.log</a:t>
+            </a:r>
+            <a:endParaRPr lang="en-US" sz="1300" dirty="0"/>
+          </a:p>
+        </p:txBody>
+      </p:sp>
+      <p:sp>
+        <p:nvSpPr>
+          <p:cNvPr id="19" name="Text 17"/>
+          <p:cNvSpPr txBox="1"/>
+          <p:nvPr/>
+        </p:nvSpPr>
+        <p:spPr>
+          <a:xfrm>
+            <a:off x="3246120" y="4837176"/>
+            <a:ext cx="2176272" cy="256032"/>
+          </a:xfrm>
+          <a:prstGeom prst="rect">
+            <a:avLst/>
+          </a:prstGeom>
+          <a:noFill/>
+          <a:ln/>
+        </p:spPr>
+        <p:txBody>
+          <a:bodyPr wrap="square" lIns="0" tIns="0" rIns="0" bIns="0" rtlCol="0" anchor="ctr">
+            <a:normAutofit/>
+          </a:bodyPr>
+          <a:lstStyle/>
+          <a:p>
+            <a:pPr algn="l" indent="0" marL="0">
+              <a:buNone/>
+            </a:pPr>
+            <a:r>
+              <a:rPr lang="en-US" sz="1200" dirty="0">
+                <a:solidFill>
+                  <a:srgbClr val="BDD8CF"/>
+                </a:solidFill>
+                <a:latin typeface="Calibri" pitchFamily="34" charset="0"/>
+                <a:ea typeface="Calibri" pitchFamily="34" charset="-122"/>
+                <a:cs typeface="Calibri" pitchFamily="34" charset="-120"/>
+              </a:rPr>
               <a:t>warnings + final counts</a:t>
             </a:r>
             <a:endParaRPr lang="en-US" sz="1200" dirty="0"/>
@@ -6824,182 +6947,18 @@
       </p:sp>
       <p:sp>
         <p:nvSpPr>
-          <p:cNvPr id="17" name="Text 15"/>
-          <p:cNvSpPr txBox="1"/>
-          <p:nvPr/>
-        </p:nvSpPr>
-        <p:spPr>
-          <a:xfrm>
-            <a:off x="978408" y="4855464"/>
-            <a:ext cx="274320" cy="256032"/>
-          </a:xfrm>
-          <a:prstGeom prst="rect">
-            <a:avLst/>
-          </a:prstGeom>
-          <a:noFill/>
-          <a:ln/>
-        </p:spPr>
-        <p:txBody>
-          <a:bodyPr wrap="square" lIns="0" tIns="0" rIns="0" bIns="0" rtlCol="0" anchor="ctr">
-            <a:normAutofit/>
-          </a:bodyPr>
-          <a:lstStyle/>
-          <a:p>
-            <a:pPr algn="l" indent="0" marL="0">
-              <a:buNone/>
-            </a:pPr>
-            <a:r>
-              <a:rPr lang="en-US" sz="1500" b="1" dirty="0">
-                <a:solidFill>
-                  <a:srgbClr val="F2C14E"/>
-                </a:solidFill>
-                <a:latin typeface="Calibri" pitchFamily="34" charset="0"/>
-                <a:ea typeface="Calibri" pitchFamily="34" charset="-122"/>
-                <a:cs typeface="Calibri" pitchFamily="34" charset="-120"/>
-              </a:rPr>
-              <a:t>↳</a:t>
-            </a:r>
-            <a:endParaRPr lang="en-US" sz="1500" dirty="0"/>
-          </a:p>
-        </p:txBody>
-      </p:sp>
-      <p:sp>
-        <p:nvSpPr>
-          <p:cNvPr id="18" name="Text 16"/>
-          <p:cNvSpPr txBox="1"/>
-          <p:nvPr/>
-        </p:nvSpPr>
-        <p:spPr>
-          <a:xfrm>
-            <a:off x="1325880" y="4855464"/>
-            <a:ext cx="2103120" cy="256032"/>
-          </a:xfrm>
-          <a:prstGeom prst="rect">
-            <a:avLst/>
-          </a:prstGeom>
-          <a:noFill/>
-          <a:ln/>
-        </p:spPr>
-        <p:txBody>
-          <a:bodyPr wrap="square" lIns="0" tIns="0" rIns="0" bIns="0" rtlCol="0" anchor="ctr">
-            <a:normAutofit/>
-          </a:bodyPr>
-          <a:lstStyle/>
-          <a:p>
-            <a:pPr algn="l" indent="0" marL="0">
-              <a:buNone/>
-            </a:pPr>
-            <a:r>
-              <a:rPr lang="en-US" sz="1300" b="1" dirty="0">
-                <a:solidFill>
-                  <a:srgbClr val="FFFFFF"/>
-                </a:solidFill>
-                <a:latin typeface="Calibri" pitchFamily="34" charset="0"/>
-                <a:ea typeface="Calibri" pitchFamily="34" charset="-122"/>
-                <a:cs typeface="Calibri" pitchFamily="34" charset="-120"/>
-              </a:rPr>
-              <a:t>README.md</a:t>
-            </a:r>
-            <a:endParaRPr lang="en-US" sz="1300" dirty="0"/>
-          </a:p>
-        </p:txBody>
-      </p:sp>
-      <p:sp>
-        <p:nvSpPr>
-          <p:cNvPr id="19" name="Text 17"/>
-          <p:cNvSpPr txBox="1"/>
-          <p:nvPr/>
-        </p:nvSpPr>
-        <p:spPr>
-          <a:xfrm>
-            <a:off x="3456432" y="4855464"/>
-            <a:ext cx="2331720" cy="256032"/>
-          </a:xfrm>
-          <a:prstGeom prst="rect">
-            <a:avLst/>
-          </a:prstGeom>
-          <a:noFill/>
-          <a:ln/>
-        </p:spPr>
-        <p:txBody>
-          <a:bodyPr wrap="square" lIns="0" tIns="0" rIns="0" bIns="0" rtlCol="0" anchor="ctr">
-            <a:normAutofit/>
-          </a:bodyPr>
-          <a:lstStyle/>
-          <a:p>
-            <a:pPr algn="l" indent="0" marL="0">
-              <a:buNone/>
-            </a:pPr>
-            <a:r>
-              <a:rPr lang="en-US" sz="1200" dirty="0">
-                <a:solidFill>
-                  <a:srgbClr val="BDD8CF"/>
-                </a:solidFill>
-                <a:latin typeface="Calibri" pitchFamily="34" charset="0"/>
-                <a:ea typeface="Calibri" pitchFamily="34" charset="-122"/>
-                <a:cs typeface="Calibri" pitchFamily="34" charset="-120"/>
-              </a:rPr>
-              <a:t>mapping · ERD · storage</a:t>
-            </a:r>
-            <a:endParaRPr lang="en-US" sz="1200" dirty="0"/>
-          </a:p>
-        </p:txBody>
-      </p:sp>
-      <p:sp>
-        <p:nvSpPr>
-          <p:cNvPr id="20" name="Text 18"/>
-          <p:cNvSpPr txBox="1"/>
-          <p:nvPr/>
-        </p:nvSpPr>
-        <p:spPr>
-          <a:xfrm>
-            <a:off x="6812280" y="2395728"/>
-            <a:ext cx="1920240" cy="310896"/>
-          </a:xfrm>
-          <a:prstGeom prst="rect">
-            <a:avLst/>
-          </a:prstGeom>
-          <a:noFill/>
-          <a:ln/>
-        </p:spPr>
-        <p:txBody>
-          <a:bodyPr wrap="square" lIns="0" tIns="0" rIns="0" bIns="0" rtlCol="0" anchor="ctr">
-            <a:normAutofit/>
-          </a:bodyPr>
-          <a:lstStyle/>
-          <a:p>
-            <a:pPr algn="l" indent="0" marL="0">
-              <a:buNone/>
-            </a:pPr>
-            <a:r>
-              <a:rPr lang="en-US" sz="1700" b="1" dirty="0">
-                <a:solidFill>
-                  <a:srgbClr val="DCEBE6"/>
-                </a:solidFill>
-                <a:latin typeface="Calibri" pitchFamily="34" charset="0"/>
-                <a:ea typeface="Calibri" pitchFamily="34" charset="-122"/>
-                <a:cs typeface="Calibri" pitchFamily="34" charset="-120"/>
-              </a:rPr>
-              <a:t>Evidence</a:t>
-            </a:r>
-            <a:endParaRPr lang="en-US" sz="1700" dirty="0"/>
-          </a:p>
-        </p:txBody>
-      </p:sp>
-      <p:sp>
-        <p:nvSpPr>
-          <p:cNvPr id="21" name="Shape 19"/>
+          <p:cNvPr id="20" name="Shape 18"/>
           <p:cNvSpPr/>
           <p:nvPr/>
         </p:nvSpPr>
         <p:spPr>
           <a:xfrm>
-            <a:off x="6812280" y="2926080"/>
-            <a:ext cx="2103120" cy="804672"/>
+            <a:off x="6172200" y="2331720"/>
+            <a:ext cx="5349240" cy="3364992"/>
           </a:xfrm>
           <a:prstGeom prst="roundRect">
             <a:avLst>
-              <a:gd name="adj" fmla="val 11364"/>
+              <a:gd name="adj" fmla="val 2717"/>
             </a:avLst>
           </a:prstGeom>
           <a:solidFill>
@@ -7015,32 +6974,73 @@
       </p:sp>
       <p:sp>
         <p:nvSpPr>
+          <p:cNvPr id="21" name="Text 19"/>
+          <p:cNvSpPr txBox="1"/>
+          <p:nvPr/>
+        </p:nvSpPr>
+        <p:spPr>
+          <a:xfrm>
+            <a:off x="6473952" y="2596896"/>
+            <a:ext cx="2011680" cy="320040"/>
+          </a:xfrm>
+          <a:prstGeom prst="rect">
+            <a:avLst/>
+          </a:prstGeom>
+          <a:noFill/>
+          <a:ln/>
+        </p:spPr>
+        <p:txBody>
+          <a:bodyPr wrap="square" lIns="0" tIns="0" rIns="0" bIns="0" rtlCol="0" anchor="ctr">
+            <a:normAutofit/>
+          </a:bodyPr>
+          <a:lstStyle/>
+          <a:p>
+            <a:pPr algn="l" indent="0" marL="0">
+              <a:buNone/>
+            </a:pPr>
+            <a:r>
+              <a:rPr lang="en-US" sz="1800" b="1" dirty="0">
+                <a:solidFill>
+                  <a:srgbClr val="102F29"/>
+                </a:solidFill>
+                <a:latin typeface="Calibri" pitchFamily="34" charset="0"/>
+                <a:ea typeface="Calibri" pitchFamily="34" charset="-122"/>
+                <a:cs typeface="Calibri" pitchFamily="34" charset="-120"/>
+              </a:rPr>
+              <a:t>model.json</a:t>
+            </a:r>
+            <a:endParaRPr lang="en-US" sz="1800" dirty="0"/>
+          </a:p>
+        </p:txBody>
+      </p:sp>
+      <p:sp>
+        <p:nvSpPr>
           <p:cNvPr id="22" name="Text 20"/>
           <p:cNvSpPr txBox="1"/>
           <p:nvPr/>
         </p:nvSpPr>
         <p:spPr>
           <a:xfrm>
-            <a:off x="6940296" y="3044952"/>
-            <a:ext cx="841248" cy="420624"/>
-          </a:xfrm>
-          <a:prstGeom prst="rect">
-            <a:avLst/>
-          </a:prstGeom>
-          <a:noFill/>
-          <a:ln/>
-        </p:spPr>
-        <p:txBody>
-          <a:bodyPr wrap="square" lIns="0" tIns="0" rIns="0" bIns="0" rtlCol="0" anchor="ctr">
-            <a:normAutofit/>
-          </a:bodyPr>
-          <a:lstStyle/>
-          <a:p>
-            <a:pPr algn="l" indent="0" marL="0">
-              <a:buNone/>
-            </a:pPr>
-            <a:r>
-              <a:rPr lang="en-US" sz="2100" b="1" dirty="0">
+            <a:off x="6492240" y="3081528"/>
+            <a:ext cx="1280160" cy="265176"/>
+          </a:xfrm>
+          <a:prstGeom prst="rect">
+            <a:avLst/>
+          </a:prstGeom>
+          <a:noFill/>
+          <a:ln/>
+        </p:spPr>
+        <p:txBody>
+          <a:bodyPr wrap="square" lIns="0" tIns="0" rIns="0" bIns="0" rtlCol="0" anchor="ctr">
+            <a:normAutofit/>
+          </a:bodyPr>
+          <a:lstStyle/>
+          <a:p>
+            <a:pPr algn="l" indent="0" marL="0">
+              <a:buNone/>
+            </a:pPr>
+            <a:r>
+              <a:rPr lang="en-US" sz="1200" b="1" dirty="0">
                 <a:solidFill>
                   <a:srgbClr val="173F35"/>
                 </a:solidFill>
@@ -7048,9 +7048,9 @@
                 <a:ea typeface="Calibri" pitchFamily="34" charset="-122"/>
                 <a:cs typeface="Calibri" pitchFamily="34" charset="-120"/>
               </a:rPr>
-              <a:t>47</a:t>
-            </a:r>
-            <a:endParaRPr lang="en-US" sz="2100" dirty="0"/>
+              <a:t>metadata</a:t>
+            </a:r>
+            <a:endParaRPr lang="en-US" sz="1200" dirty="0"/>
           </a:p>
         </p:txBody>
       </p:sp>
@@ -7062,26 +7062,26 @@
         </p:nvSpPr>
         <p:spPr>
           <a:xfrm>
-            <a:off x="7744968" y="3090672"/>
-            <a:ext cx="1024128" cy="347472"/>
-          </a:xfrm>
-          <a:prstGeom prst="rect">
-            <a:avLst/>
-          </a:prstGeom>
-          <a:noFill/>
-          <a:ln/>
-        </p:spPr>
-        <p:txBody>
-          <a:bodyPr wrap="square" lIns="0" tIns="0" rIns="0" bIns="0" rtlCol="0" anchor="ctr">
-            <a:normAutofit/>
-          </a:bodyPr>
-          <a:lstStyle/>
-          <a:p>
-            <a:pPr algn="l" indent="0" marL="0">
-              <a:buNone/>
-            </a:pPr>
-            <a:r>
-              <a:rPr lang="en-US" sz="1100" b="1" dirty="0">
+            <a:off x="7909560" y="3081528"/>
+            <a:ext cx="3154680" cy="265176"/>
+          </a:xfrm>
+          <a:prstGeom prst="rect">
+            <a:avLst/>
+          </a:prstGeom>
+          <a:noFill/>
+          <a:ln/>
+        </p:spPr>
+        <p:txBody>
+          <a:bodyPr wrap="square" lIns="0" tIns="0" rIns="0" bIns="0" rtlCol="0" anchor="ctr">
+            <a:normAutofit/>
+          </a:bodyPr>
+          <a:lstStyle/>
+          <a:p>
+            <a:pPr algn="l" indent="0" marL="0">
+              <a:buNone/>
+            </a:pPr>
+            <a:r>
+              <a:rPr lang="en-US" sz="1200" dirty="0">
                 <a:solidFill>
                   <a:srgbClr val="5E6C67"/>
                 </a:solidFill>
@@ -7089,116 +7089,400 @@
                 <a:ea typeface="Calibri" pitchFamily="34" charset="-122"/>
                 <a:cs typeface="Calibri" pitchFamily="34" charset="-120"/>
               </a:rPr>
-              <a:t>tests passed</a:t>
-            </a:r>
-            <a:endParaRPr lang="en-US" sz="1100" dirty="0"/>
-          </a:p>
-        </p:txBody>
-      </p:sp>
-      <p:sp>
-        <p:nvSpPr>
-          <p:cNvPr id="24" name="Shape 22"/>
+              <a:t>name · description · version</a:t>
+            </a:r>
+            <a:endParaRPr lang="en-US" sz="1200" dirty="0"/>
+          </a:p>
+        </p:txBody>
+      </p:sp>
+      <p:sp>
+        <p:nvSpPr>
+          <p:cNvPr id="24" name="Text 22"/>
+          <p:cNvSpPr txBox="1"/>
+          <p:nvPr/>
+        </p:nvSpPr>
+        <p:spPr>
+          <a:xfrm>
+            <a:off x="6492240" y="3557016"/>
+            <a:ext cx="1280160" cy="265176"/>
+          </a:xfrm>
+          <a:prstGeom prst="rect">
+            <a:avLst/>
+          </a:prstGeom>
+          <a:noFill/>
+          <a:ln/>
+        </p:spPr>
+        <p:txBody>
+          <a:bodyPr wrap="square" lIns="0" tIns="0" rIns="0" bIns="0" rtlCol="0" anchor="ctr">
+            <a:normAutofit/>
+          </a:bodyPr>
+          <a:lstStyle/>
+          <a:p>
+            <a:pPr algn="l" indent="0" marL="0">
+              <a:buNone/>
+            </a:pPr>
+            <a:r>
+              <a:rPr lang="en-US" sz="1200" b="1" dirty="0">
+                <a:solidFill>
+                  <a:srgbClr val="173F35"/>
+                </a:solidFill>
+                <a:latin typeface="Calibri" pitchFamily="34" charset="0"/>
+                <a:ea typeface="Calibri" pitchFamily="34" charset="-122"/>
+                <a:cs typeface="Calibri" pitchFamily="34" charset="-120"/>
+              </a:rPr>
+              <a:t>entities</a:t>
+            </a:r>
+            <a:endParaRPr lang="en-US" sz="1200" dirty="0"/>
+          </a:p>
+        </p:txBody>
+      </p:sp>
+      <p:sp>
+        <p:nvSpPr>
+          <p:cNvPr id="25" name="Text 23"/>
+          <p:cNvSpPr txBox="1"/>
+          <p:nvPr/>
+        </p:nvSpPr>
+        <p:spPr>
+          <a:xfrm>
+            <a:off x="7909560" y="3557016"/>
+            <a:ext cx="3154680" cy="265176"/>
+          </a:xfrm>
+          <a:prstGeom prst="rect">
+            <a:avLst/>
+          </a:prstGeom>
+          <a:noFill/>
+          <a:ln/>
+        </p:spPr>
+        <p:txBody>
+          <a:bodyPr wrap="square" lIns="0" tIns="0" rIns="0" bIns="0" rtlCol="0" anchor="ctr">
+            <a:normAutofit/>
+          </a:bodyPr>
+          <a:lstStyle/>
+          <a:p>
+            <a:pPr algn="l" indent="0" marL="0">
+              <a:buNone/>
+            </a:pPr>
+            <a:r>
+              <a:rPr lang="en-US" sz="1200" dirty="0">
+                <a:solidFill>
+                  <a:srgbClr val="5E6C67"/>
+                </a:solidFill>
+                <a:latin typeface="Calibri" pitchFamily="34" charset="0"/>
+                <a:ea typeface="Calibri" pitchFamily="34" charset="-122"/>
+                <a:cs typeface="Calibri" pitchFamily="34" charset="-120"/>
+              </a:rPr>
+              <a:t>Contact · SalesOrder</a:t>
+            </a:r>
+            <a:endParaRPr lang="en-US" sz="1200" dirty="0"/>
+          </a:p>
+        </p:txBody>
+      </p:sp>
+      <p:sp>
+        <p:nvSpPr>
+          <p:cNvPr id="26" name="Text 24"/>
+          <p:cNvSpPr txBox="1"/>
+          <p:nvPr/>
+        </p:nvSpPr>
+        <p:spPr>
+          <a:xfrm>
+            <a:off x="6492240" y="4032504"/>
+            <a:ext cx="1280160" cy="265176"/>
+          </a:xfrm>
+          <a:prstGeom prst="rect">
+            <a:avLst/>
+          </a:prstGeom>
+          <a:noFill/>
+          <a:ln/>
+        </p:spPr>
+        <p:txBody>
+          <a:bodyPr wrap="square" lIns="0" tIns="0" rIns="0" bIns="0" rtlCol="0" anchor="ctr">
+            <a:normAutofit/>
+          </a:bodyPr>
+          <a:lstStyle/>
+          <a:p>
+            <a:pPr algn="l" indent="0" marL="0">
+              <a:buNone/>
+            </a:pPr>
+            <a:r>
+              <a:rPr lang="en-US" sz="1200" b="1" dirty="0">
+                <a:solidFill>
+                  <a:srgbClr val="173F35"/>
+                </a:solidFill>
+                <a:latin typeface="Calibri" pitchFamily="34" charset="0"/>
+                <a:ea typeface="Calibri" pitchFamily="34" charset="-122"/>
+                <a:cs typeface="Calibri" pitchFamily="34" charset="-120"/>
+              </a:rPr>
+              <a:t>attributes</a:t>
+            </a:r>
+            <a:endParaRPr lang="en-US" sz="1200" dirty="0"/>
+          </a:p>
+        </p:txBody>
+      </p:sp>
+      <p:sp>
+        <p:nvSpPr>
+          <p:cNvPr id="27" name="Text 25"/>
+          <p:cNvSpPr txBox="1"/>
+          <p:nvPr/>
+        </p:nvSpPr>
+        <p:spPr>
+          <a:xfrm>
+            <a:off x="7909560" y="4032504"/>
+            <a:ext cx="3154680" cy="265176"/>
+          </a:xfrm>
+          <a:prstGeom prst="rect">
+            <a:avLst/>
+          </a:prstGeom>
+          <a:noFill/>
+          <a:ln/>
+        </p:spPr>
+        <p:txBody>
+          <a:bodyPr wrap="square" lIns="0" tIns="0" rIns="0" bIns="0" rtlCol="0" anchor="ctr">
+            <a:normAutofit/>
+          </a:bodyPr>
+          <a:lstStyle/>
+          <a:p>
+            <a:pPr algn="l" indent="0" marL="0">
+              <a:buNone/>
+            </a:pPr>
+            <a:r>
+              <a:rPr lang="en-US" sz="1200" dirty="0">
+                <a:solidFill>
+                  <a:srgbClr val="5E6C67"/>
+                </a:solidFill>
+                <a:latin typeface="Calibri" pitchFamily="34" charset="0"/>
+                <a:ea typeface="Calibri" pitchFamily="34" charset="-122"/>
+                <a:cs typeface="Calibri" pitchFamily="34" charset="-120"/>
+              </a:rPr>
+              <a:t>name · CDM dataType</a:t>
+            </a:r>
+            <a:endParaRPr lang="en-US" sz="1200" dirty="0"/>
+          </a:p>
+        </p:txBody>
+      </p:sp>
+      <p:sp>
+        <p:nvSpPr>
+          <p:cNvPr id="28" name="Text 26"/>
+          <p:cNvSpPr txBox="1"/>
+          <p:nvPr/>
+        </p:nvSpPr>
+        <p:spPr>
+          <a:xfrm>
+            <a:off x="6492240" y="4507992"/>
+            <a:ext cx="1280160" cy="265176"/>
+          </a:xfrm>
+          <a:prstGeom prst="rect">
+            <a:avLst/>
+          </a:prstGeom>
+          <a:noFill/>
+          <a:ln/>
+        </p:spPr>
+        <p:txBody>
+          <a:bodyPr wrap="square" lIns="0" tIns="0" rIns="0" bIns="0" rtlCol="0" anchor="ctr">
+            <a:normAutofit/>
+          </a:bodyPr>
+          <a:lstStyle/>
+          <a:p>
+            <a:pPr algn="l" indent="0" marL="0">
+              <a:buNone/>
+            </a:pPr>
+            <a:r>
+              <a:rPr lang="en-US" sz="1200" b="1" dirty="0">
+                <a:solidFill>
+                  <a:srgbClr val="173F35"/>
+                </a:solidFill>
+                <a:latin typeface="Calibri" pitchFamily="34" charset="0"/>
+                <a:ea typeface="Calibri" pitchFamily="34" charset="-122"/>
+                <a:cs typeface="Calibri" pitchFamily="34" charset="-120"/>
+              </a:rPr>
+              <a:t>partitions</a:t>
+            </a:r>
+            <a:endParaRPr lang="en-US" sz="1200" dirty="0"/>
+          </a:p>
+        </p:txBody>
+      </p:sp>
+      <p:sp>
+        <p:nvSpPr>
+          <p:cNvPr id="29" name="Text 27"/>
+          <p:cNvSpPr txBox="1"/>
+          <p:nvPr/>
+        </p:nvSpPr>
+        <p:spPr>
+          <a:xfrm>
+            <a:off x="7909560" y="4507992"/>
+            <a:ext cx="3154680" cy="265176"/>
+          </a:xfrm>
+          <a:prstGeom prst="rect">
+            <a:avLst/>
+          </a:prstGeom>
+          <a:noFill/>
+          <a:ln/>
+        </p:spPr>
+        <p:txBody>
+          <a:bodyPr wrap="square" lIns="0" tIns="0" rIns="0" bIns="0" rtlCol="0" anchor="ctr">
+            <a:normAutofit/>
+          </a:bodyPr>
+          <a:lstStyle/>
+          <a:p>
+            <a:pPr algn="l" indent="0" marL="0">
+              <a:buNone/>
+            </a:pPr>
+            <a:r>
+              <a:rPr lang="en-US" sz="1200" dirty="0">
+                <a:solidFill>
+                  <a:srgbClr val="5E6C67"/>
+                </a:solidFill>
+                <a:latin typeface="Calibri" pitchFamily="34" charset="0"/>
+                <a:ea typeface="Calibri" pitchFamily="34" charset="-122"/>
+                <a:cs typeface="Calibri" pitchFamily="34" charset="-120"/>
+              </a:rPr>
+              <a:t>relative CSV locations</a:t>
+            </a:r>
+            <a:endParaRPr lang="en-US" sz="1200" dirty="0"/>
+          </a:p>
+        </p:txBody>
+      </p:sp>
+      <p:sp>
+        <p:nvSpPr>
+          <p:cNvPr id="30" name="Text 28"/>
+          <p:cNvSpPr txBox="1"/>
+          <p:nvPr/>
+        </p:nvSpPr>
+        <p:spPr>
+          <a:xfrm>
+            <a:off x="6492240" y="4983480"/>
+            <a:ext cx="1280160" cy="265176"/>
+          </a:xfrm>
+          <a:prstGeom prst="rect">
+            <a:avLst/>
+          </a:prstGeom>
+          <a:noFill/>
+          <a:ln/>
+        </p:spPr>
+        <p:txBody>
+          <a:bodyPr wrap="square" lIns="0" tIns="0" rIns="0" bIns="0" rtlCol="0" anchor="ctr">
+            <a:normAutofit/>
+          </a:bodyPr>
+          <a:lstStyle/>
+          <a:p>
+            <a:pPr algn="l" indent="0" marL="0">
+              <a:buNone/>
+            </a:pPr>
+            <a:r>
+              <a:rPr lang="en-US" sz="1200" b="1" dirty="0">
+                <a:solidFill>
+                  <a:srgbClr val="173F35"/>
+                </a:solidFill>
+                <a:latin typeface="Calibri" pitchFamily="34" charset="0"/>
+                <a:ea typeface="Calibri" pitchFamily="34" charset="-122"/>
+                <a:cs typeface="Calibri" pitchFamily="34" charset="-120"/>
+              </a:rPr>
+              <a:t>relationship</a:t>
+            </a:r>
+            <a:endParaRPr lang="en-US" sz="1200" dirty="0"/>
+          </a:p>
+        </p:txBody>
+      </p:sp>
+      <p:sp>
+        <p:nvSpPr>
+          <p:cNvPr id="31" name="Text 29"/>
+          <p:cNvSpPr txBox="1"/>
+          <p:nvPr/>
+        </p:nvSpPr>
+        <p:spPr>
+          <a:xfrm>
+            <a:off x="7909560" y="4983480"/>
+            <a:ext cx="3154680" cy="265176"/>
+          </a:xfrm>
+          <a:prstGeom prst="rect">
+            <a:avLst/>
+          </a:prstGeom>
+          <a:noFill/>
+          <a:ln/>
+        </p:spPr>
+        <p:txBody>
+          <a:bodyPr wrap="square" lIns="0" tIns="0" rIns="0" bIns="0" rtlCol="0" anchor="ctr">
+            <a:normAutofit/>
+          </a:bodyPr>
+          <a:lstStyle/>
+          <a:p>
+            <a:pPr algn="l" indent="0" marL="0">
+              <a:buNone/>
+            </a:pPr>
+            <a:r>
+              <a:rPr lang="en-US" sz="1200" dirty="0">
+                <a:solidFill>
+                  <a:srgbClr val="5E6C67"/>
+                </a:solidFill>
+                <a:latin typeface="Calibri" pitchFamily="34" charset="0"/>
+                <a:ea typeface="Calibri" pitchFamily="34" charset="-122"/>
+                <a:cs typeface="Calibri" pitchFamily="34" charset="-120"/>
+              </a:rPr>
+              <a:t>customerid → contactid</a:t>
+            </a:r>
+            <a:endParaRPr lang="en-US" sz="1200" dirty="0"/>
+          </a:p>
+        </p:txBody>
+      </p:sp>
+      <p:sp>
+        <p:nvSpPr>
+          <p:cNvPr id="32" name="Shape 30"/>
           <p:cNvSpPr/>
           <p:nvPr/>
         </p:nvSpPr>
         <p:spPr>
           <a:xfrm>
-            <a:off x="9208008" y="2926080"/>
-            <a:ext cx="2103120" cy="804672"/>
-          </a:xfrm>
-          <a:prstGeom prst="roundRect">
-            <a:avLst>
-              <a:gd name="adj" fmla="val 11364"/>
-            </a:avLst>
-          </a:prstGeom>
-          <a:solidFill>
-            <a:srgbClr val="FFF5D9"/>
-          </a:solidFill>
-          <a:ln w="12700">
+            <a:off x="5468112" y="3941064"/>
+            <a:ext cx="539496" cy="0"/>
+          </a:xfrm>
+          <a:prstGeom prst="line">
+            <a:avLst/>
+          </a:prstGeom>
+          <a:noFill/>
+          <a:ln w="38100">
             <a:solidFill>
-              <a:srgbClr val="FFF5D9"/>
+              <a:srgbClr val="F2C14E"/>
             </a:solidFill>
             <a:prstDash val="solid"/>
+            <a:tailEnd type="triangle"/>
           </a:ln>
         </p:spPr>
       </p:sp>
       <p:sp>
         <p:nvSpPr>
-          <p:cNvPr id="25" name="Text 23"/>
-          <p:cNvSpPr txBox="1"/>
-          <p:nvPr/>
-        </p:nvSpPr>
-        <p:spPr>
-          <a:xfrm>
-            <a:off x="9336024" y="3044952"/>
-            <a:ext cx="841248" cy="420624"/>
-          </a:xfrm>
-          <a:prstGeom prst="rect">
-            <a:avLst/>
-          </a:prstGeom>
-          <a:noFill/>
-          <a:ln/>
-        </p:spPr>
-        <p:txBody>
-          <a:bodyPr wrap="square" lIns="0" tIns="0" rIns="0" bIns="0" rtlCol="0" anchor="ctr">
-            <a:normAutofit/>
-          </a:bodyPr>
-          <a:lstStyle/>
-          <a:p>
-            <a:pPr algn="l" indent="0" marL="0">
-              <a:buNone/>
-            </a:pPr>
-            <a:r>
-              <a:rPr lang="en-US" sz="2100" b="1" dirty="0">
-                <a:solidFill>
-                  <a:srgbClr val="102F29"/>
-                </a:solidFill>
-                <a:latin typeface="Calibri" pitchFamily="34" charset="0"/>
-                <a:ea typeface="Calibri" pitchFamily="34" charset="-122"/>
-                <a:cs typeface="Calibri" pitchFamily="34" charset="-120"/>
-              </a:rPr>
-              <a:t>98.93%</a:t>
-            </a:r>
-            <a:endParaRPr lang="en-US" sz="2100" dirty="0"/>
-          </a:p>
-        </p:txBody>
-      </p:sp>
-      <p:sp>
-        <p:nvSpPr>
-          <p:cNvPr id="26" name="Text 24"/>
-          <p:cNvSpPr txBox="1"/>
-          <p:nvPr/>
-        </p:nvSpPr>
-        <p:spPr>
-          <a:xfrm>
-            <a:off x="10140696" y="3090672"/>
-            <a:ext cx="1024128" cy="347472"/>
-          </a:xfrm>
-          <a:prstGeom prst="rect">
-            <a:avLst/>
-          </a:prstGeom>
-          <a:noFill/>
-          <a:ln/>
-        </p:spPr>
-        <p:txBody>
-          <a:bodyPr wrap="square" lIns="0" tIns="0" rIns="0" bIns="0" rtlCol="0" anchor="ctr">
-            <a:normAutofit/>
-          </a:bodyPr>
-          <a:lstStyle/>
-          <a:p>
-            <a:pPr algn="l" indent="0" marL="0">
+          <p:cNvPr id="33" name="Text 31"/>
+          <p:cNvSpPr txBox="1"/>
+          <p:nvPr/>
+        </p:nvSpPr>
+        <p:spPr>
+          <a:xfrm>
+            <a:off x="5047488" y="3493008"/>
+            <a:ext cx="1353312" cy="246888"/>
+          </a:xfrm>
+          <a:prstGeom prst="rect">
+            <a:avLst/>
+          </a:prstGeom>
+          <a:noFill/>
+          <a:ln/>
+        </p:spPr>
+        <p:txBody>
+          <a:bodyPr wrap="square" lIns="0" tIns="0" rIns="0" bIns="0" rtlCol="0" anchor="ctr">
+            <a:normAutofit/>
+          </a:bodyPr>
+          <a:lstStyle/>
+          <a:p>
+            <a:pPr algn="ctr" indent="0" marL="0">
               <a:buNone/>
             </a:pPr>
             <a:r>
               <a:rPr lang="en-US" sz="1100" b="1" dirty="0">
                 <a:solidFill>
-                  <a:srgbClr val="102F29"/>
-                </a:solidFill>
-                <a:latin typeface="Calibri" pitchFamily="34" charset="0"/>
-                <a:ea typeface="Calibri" pitchFamily="34" charset="-122"/>
-                <a:cs typeface="Calibri" pitchFamily="34" charset="-120"/>
-              </a:rPr>
-              <a:t>coverage</a:t>
+                  <a:srgbClr val="F2C14E"/>
+                </a:solidFill>
+                <a:latin typeface="Calibri" pitchFamily="34" charset="0"/>
+                <a:ea typeface="Calibri" pitchFamily="34" charset="-122"/>
+                <a:cs typeface="Calibri" pitchFamily="34" charset="-120"/>
+              </a:rPr>
+              <a:t>same models</a:t>
             </a:r>
             <a:endParaRPr lang="en-US" sz="1100" dirty="0"/>
           </a:p>
@@ -7206,298 +7490,14 @@
       </p:sp>
       <p:sp>
         <p:nvSpPr>
-          <p:cNvPr id="27" name="Shape 25"/>
-          <p:cNvSpPr/>
-          <p:nvPr/>
-        </p:nvSpPr>
-        <p:spPr>
-          <a:xfrm>
-            <a:off x="6812280" y="3977640"/>
-            <a:ext cx="2103120" cy="804672"/>
-          </a:xfrm>
-          <a:prstGeom prst="roundRect">
-            <a:avLst>
-              <a:gd name="adj" fmla="val 11364"/>
-            </a:avLst>
-          </a:prstGeom>
-          <a:solidFill>
-            <a:srgbClr val="FFFFFF"/>
-          </a:solidFill>
-          <a:ln w="12700">
-            <a:solidFill>
-              <a:srgbClr val="FFFFFF"/>
-            </a:solidFill>
-            <a:prstDash val="solid"/>
-          </a:ln>
-        </p:spPr>
-      </p:sp>
-      <p:sp>
-        <p:nvSpPr>
-          <p:cNvPr id="28" name="Text 26"/>
-          <p:cNvSpPr txBox="1"/>
-          <p:nvPr/>
-        </p:nvSpPr>
-        <p:spPr>
-          <a:xfrm>
-            <a:off x="6940296" y="4096512"/>
-            <a:ext cx="841248" cy="420624"/>
-          </a:xfrm>
-          <a:prstGeom prst="rect">
-            <a:avLst/>
-          </a:prstGeom>
-          <a:noFill/>
-          <a:ln/>
-        </p:spPr>
-        <p:txBody>
-          <a:bodyPr wrap="square" lIns="0" tIns="0" rIns="0" bIns="0" rtlCol="0" anchor="ctr">
-            <a:normAutofit/>
-          </a:bodyPr>
-          <a:lstStyle/>
-          <a:p>
-            <a:pPr algn="l" indent="0" marL="0">
-              <a:buNone/>
-            </a:pPr>
-            <a:r>
-              <a:rPr lang="en-US" sz="2100" b="1" dirty="0">
-                <a:solidFill>
-                  <a:srgbClr val="173F35"/>
-                </a:solidFill>
-                <a:latin typeface="Calibri" pitchFamily="34" charset="0"/>
-                <a:ea typeface="Calibri" pitchFamily="34" charset="-122"/>
-                <a:cs typeface="Calibri" pitchFamily="34" charset="-120"/>
-              </a:rPr>
-              <a:t>2</a:t>
-            </a:r>
-            <a:endParaRPr lang="en-US" sz="2100" dirty="0"/>
-          </a:p>
-        </p:txBody>
-      </p:sp>
-      <p:sp>
-        <p:nvSpPr>
-          <p:cNvPr id="29" name="Text 27"/>
-          <p:cNvSpPr txBox="1"/>
-          <p:nvPr/>
-        </p:nvSpPr>
-        <p:spPr>
-          <a:xfrm>
-            <a:off x="7744968" y="4142232"/>
-            <a:ext cx="1024128" cy="347472"/>
-          </a:xfrm>
-          <a:prstGeom prst="rect">
-            <a:avLst/>
-          </a:prstGeom>
-          <a:noFill/>
-          <a:ln/>
-        </p:spPr>
-        <p:txBody>
-          <a:bodyPr wrap="square" lIns="0" tIns="0" rIns="0" bIns="0" rtlCol="0" anchor="ctr">
-            <a:normAutofit/>
-          </a:bodyPr>
-          <a:lstStyle/>
-          <a:p>
-            <a:pPr algn="l" indent="0" marL="0">
-              <a:buNone/>
-            </a:pPr>
-            <a:r>
-              <a:rPr lang="en-US" sz="1100" b="1" dirty="0">
-                <a:solidFill>
-                  <a:srgbClr val="5E6C67"/>
-                </a:solidFill>
-                <a:latin typeface="Calibri" pitchFamily="34" charset="0"/>
-                <a:ea typeface="Calibri" pitchFamily="34" charset="-122"/>
-                <a:cs typeface="Calibri" pitchFamily="34" charset="-120"/>
-              </a:rPr>
-              <a:t>Python versions</a:t>
-            </a:r>
-            <a:endParaRPr lang="en-US" sz="1100" dirty="0"/>
-          </a:p>
-        </p:txBody>
-      </p:sp>
-      <p:sp>
-        <p:nvSpPr>
-          <p:cNvPr id="30" name="Shape 28"/>
-          <p:cNvSpPr/>
-          <p:nvPr/>
-        </p:nvSpPr>
-        <p:spPr>
-          <a:xfrm>
-            <a:off x="9208008" y="3977640"/>
-            <a:ext cx="2103120" cy="804672"/>
-          </a:xfrm>
-          <a:prstGeom prst="roundRect">
-            <a:avLst>
-              <a:gd name="adj" fmla="val 11364"/>
-            </a:avLst>
-          </a:prstGeom>
-          <a:solidFill>
-            <a:srgbClr val="FFFFFF"/>
-          </a:solidFill>
-          <a:ln w="12700">
-            <a:solidFill>
-              <a:srgbClr val="FFFFFF"/>
-            </a:solidFill>
-            <a:prstDash val="solid"/>
-          </a:ln>
-        </p:spPr>
-      </p:sp>
-      <p:sp>
-        <p:nvSpPr>
-          <p:cNvPr id="31" name="Text 29"/>
-          <p:cNvSpPr txBox="1"/>
-          <p:nvPr/>
-        </p:nvSpPr>
-        <p:spPr>
-          <a:xfrm>
-            <a:off x="9336024" y="4096512"/>
-            <a:ext cx="841248" cy="420624"/>
-          </a:xfrm>
-          <a:prstGeom prst="rect">
-            <a:avLst/>
-          </a:prstGeom>
-          <a:noFill/>
-          <a:ln/>
-        </p:spPr>
-        <p:txBody>
-          <a:bodyPr wrap="square" lIns="0" tIns="0" rIns="0" bIns="0" rtlCol="0" anchor="ctr">
-            <a:normAutofit/>
-          </a:bodyPr>
-          <a:lstStyle/>
-          <a:p>
-            <a:pPr algn="l" indent="0" marL="0">
-              <a:buNone/>
-            </a:pPr>
-            <a:r>
-              <a:rPr lang="en-US" sz="2100" b="1" dirty="0">
-                <a:solidFill>
-                  <a:srgbClr val="173F35"/>
-                </a:solidFill>
-                <a:latin typeface="Calibri" pitchFamily="34" charset="0"/>
-                <a:ea typeface="Calibri" pitchFamily="34" charset="-122"/>
-                <a:cs typeface="Calibri" pitchFamily="34" charset="-120"/>
-              </a:rPr>
-              <a:t>3</a:t>
-            </a:r>
-            <a:endParaRPr lang="en-US" sz="2100" dirty="0"/>
-          </a:p>
-        </p:txBody>
-      </p:sp>
-      <p:sp>
-        <p:nvSpPr>
-          <p:cNvPr id="32" name="Text 30"/>
-          <p:cNvSpPr txBox="1"/>
-          <p:nvPr/>
-        </p:nvSpPr>
-        <p:spPr>
-          <a:xfrm>
-            <a:off x="10140696" y="4142232"/>
-            <a:ext cx="1024128" cy="347472"/>
-          </a:xfrm>
-          <a:prstGeom prst="rect">
-            <a:avLst/>
-          </a:prstGeom>
-          <a:noFill/>
-          <a:ln/>
-        </p:spPr>
-        <p:txBody>
-          <a:bodyPr wrap="square" lIns="0" tIns="0" rIns="0" bIns="0" rtlCol="0" anchor="ctr">
-            <a:normAutofit/>
-          </a:bodyPr>
-          <a:lstStyle/>
-          <a:p>
-            <a:pPr algn="l" indent="0" marL="0">
-              <a:buNone/>
-            </a:pPr>
-            <a:r>
-              <a:rPr lang="en-US" sz="1100" b="1" dirty="0">
-                <a:solidFill>
-                  <a:srgbClr val="5E6C67"/>
-                </a:solidFill>
-                <a:latin typeface="Calibri" pitchFamily="34" charset="0"/>
-                <a:ea typeface="Calibri" pitchFamily="34" charset="-122"/>
-                <a:cs typeface="Calibri" pitchFamily="34" charset="-120"/>
-              </a:rPr>
-              <a:t>README diagrams</a:t>
-            </a:r>
-            <a:endParaRPr lang="en-US" sz="1100" dirty="0"/>
-          </a:p>
-        </p:txBody>
-      </p:sp>
-      <p:sp>
-        <p:nvSpPr>
-          <p:cNvPr id="33" name="Shape 31"/>
-          <p:cNvSpPr/>
-          <p:nvPr/>
-        </p:nvSpPr>
-        <p:spPr>
-          <a:xfrm>
-            <a:off x="6839712" y="5193792"/>
-            <a:ext cx="246888" cy="246888"/>
-          </a:xfrm>
-          <a:prstGeom prst="ellipse">
-            <a:avLst/>
-          </a:prstGeom>
-          <a:solidFill>
-            <a:srgbClr val="55B99A"/>
-          </a:solidFill>
-          <a:ln w="12700">
-            <a:solidFill>
-              <a:srgbClr val="55B99A"/>
-            </a:solidFill>
-            <a:prstDash val="solid"/>
-          </a:ln>
-        </p:spPr>
-      </p:sp>
-      <p:sp>
-        <p:nvSpPr>
           <p:cNvPr id="34" name="Text 32"/>
           <p:cNvSpPr txBox="1"/>
           <p:nvPr/>
         </p:nvSpPr>
         <p:spPr>
           <a:xfrm>
-            <a:off x="6839712" y="5184648"/>
-            <a:ext cx="246888" cy="246888"/>
-          </a:xfrm>
-          <a:prstGeom prst="rect">
-            <a:avLst/>
-          </a:prstGeom>
-          <a:noFill/>
-          <a:ln/>
-        </p:spPr>
-        <p:txBody>
-          <a:bodyPr wrap="square" lIns="0" tIns="0" rIns="0" bIns="0" rtlCol="0" anchor="ctr">
-            <a:normAutofit/>
-          </a:bodyPr>
-          <a:lstStyle/>
-          <a:p>
-            <a:pPr algn="ctr" indent="0" marL="0">
-              <a:buNone/>
-            </a:pPr>
-            <a:r>
-              <a:rPr lang="en-US" sz="1200" b="1" dirty="0">
-                <a:solidFill>
-                  <a:srgbClr val="FFFFFF"/>
-                </a:solidFill>
-                <a:latin typeface="Calibri" pitchFamily="34" charset="0"/>
-                <a:ea typeface="Calibri" pitchFamily="34" charset="-122"/>
-                <a:cs typeface="Calibri" pitchFamily="34" charset="-120"/>
-              </a:rPr>
-              <a:t>✓</a:t>
-            </a:r>
-            <a:endParaRPr lang="en-US" sz="1200" dirty="0"/>
-          </a:p>
-        </p:txBody>
-      </p:sp>
-      <p:sp>
-        <p:nvSpPr>
-          <p:cNvPr id="35" name="Text 33"/>
-          <p:cNvSpPr txBox="1"/>
-          <p:nvPr/>
-        </p:nvSpPr>
-        <p:spPr>
-          <a:xfrm>
-            <a:off x="7205472" y="5138928"/>
-            <a:ext cx="3474720" cy="356616"/>
+            <a:off x="658368" y="6016752"/>
+            <a:ext cx="7589520" cy="274320"/>
           </a:xfrm>
           <a:prstGeom prst="rect">
             <a:avLst/>
@@ -7517,161 +7517,13 @@
             <a:r>
               <a:rPr lang="en-US" sz="1300" b="1" dirty="0">
                 <a:solidFill>
-                  <a:srgbClr val="DCEBE6"/>
-                </a:solidFill>
-                <a:latin typeface="Calibri" pitchFamily="34" charset="0"/>
-                <a:ea typeface="Calibri" pitchFamily="34" charset="-122"/>
-                <a:cs typeface="Calibri" pitchFamily="34" charset="-120"/>
-              </a:rPr>
-              <a:t>CI green: Python 3.11 + 3.13</a:t>
-            </a:r>
-            <a:endParaRPr lang="en-US" sz="1300" dirty="0"/>
-          </a:p>
-        </p:txBody>
-      </p:sp>
-      <p:sp>
-        <p:nvSpPr>
-          <p:cNvPr id="36" name="Shape 34"/>
-          <p:cNvSpPr/>
-          <p:nvPr/>
-        </p:nvSpPr>
-        <p:spPr>
-          <a:xfrm>
-            <a:off x="6839712" y="5641848"/>
-            <a:ext cx="246888" cy="246888"/>
-          </a:xfrm>
-          <a:prstGeom prst="ellipse">
-            <a:avLst/>
-          </a:prstGeom>
-          <a:solidFill>
-            <a:srgbClr val="55B99A"/>
-          </a:solidFill>
-          <a:ln w="12700">
-            <a:solidFill>
-              <a:srgbClr val="55B99A"/>
-            </a:solidFill>
-            <a:prstDash val="solid"/>
-          </a:ln>
-        </p:spPr>
-      </p:sp>
-      <p:sp>
-        <p:nvSpPr>
-          <p:cNvPr id="37" name="Text 35"/>
-          <p:cNvSpPr txBox="1"/>
-          <p:nvPr/>
-        </p:nvSpPr>
-        <p:spPr>
-          <a:xfrm>
-            <a:off x="6839712" y="5632704"/>
-            <a:ext cx="246888" cy="246888"/>
-          </a:xfrm>
-          <a:prstGeom prst="rect">
-            <a:avLst/>
-          </a:prstGeom>
-          <a:noFill/>
-          <a:ln/>
-        </p:spPr>
-        <p:txBody>
-          <a:bodyPr wrap="square" lIns="0" tIns="0" rIns="0" bIns="0" rtlCol="0" anchor="ctr">
-            <a:normAutofit/>
-          </a:bodyPr>
-          <a:lstStyle/>
-          <a:p>
-            <a:pPr algn="ctr" indent="0" marL="0">
-              <a:buNone/>
-            </a:pPr>
-            <a:r>
-              <a:rPr lang="en-US" sz="1200" b="1" dirty="0">
-                <a:solidFill>
-                  <a:srgbClr val="FFFFFF"/>
-                </a:solidFill>
-                <a:latin typeface="Calibri" pitchFamily="34" charset="0"/>
-                <a:ea typeface="Calibri" pitchFamily="34" charset="-122"/>
-                <a:cs typeface="Calibri" pitchFamily="34" charset="-120"/>
-              </a:rPr>
-              <a:t>✓</a:t>
-            </a:r>
-            <a:endParaRPr lang="en-US" sz="1200" dirty="0"/>
-          </a:p>
-        </p:txBody>
-      </p:sp>
-      <p:sp>
-        <p:nvSpPr>
-          <p:cNvPr id="38" name="Text 36"/>
-          <p:cNvSpPr txBox="1"/>
-          <p:nvPr/>
-        </p:nvSpPr>
-        <p:spPr>
-          <a:xfrm>
-            <a:off x="7205472" y="5586984"/>
-            <a:ext cx="3474720" cy="356616"/>
-          </a:xfrm>
-          <a:prstGeom prst="rect">
-            <a:avLst/>
-          </a:prstGeom>
-          <a:noFill/>
-          <a:ln/>
-        </p:spPr>
-        <p:txBody>
-          <a:bodyPr wrap="square" lIns="0" tIns="0" rIns="0" bIns="0" rtlCol="0" anchor="ctr">
-            <a:normAutofit/>
-          </a:bodyPr>
-          <a:lstStyle/>
-          <a:p>
-            <a:pPr algn="l" indent="0" marL="0">
-              <a:buNone/>
-            </a:pPr>
-            <a:r>
-              <a:rPr lang="en-US" sz="1300" b="1" dirty="0">
-                <a:solidFill>
-                  <a:srgbClr val="DCEBE6"/>
-                </a:solidFill>
-                <a:latin typeface="Calibri" pitchFamily="34" charset="0"/>
-                <a:ea typeface="Calibri" pitchFamily="34" charset="-122"/>
-                <a:cs typeface="Calibri" pitchFamily="34" charset="-120"/>
-              </a:rPr>
-              <a:t>Manifest reference + schema checks</a:t>
-            </a:r>
-            <a:endParaRPr lang="en-US" sz="1300" dirty="0"/>
-          </a:p>
-        </p:txBody>
-      </p:sp>
-      <p:sp>
-        <p:nvSpPr>
-          <p:cNvPr id="39" name="Text 37"/>
-          <p:cNvSpPr txBox="1"/>
-          <p:nvPr/>
-        </p:nvSpPr>
-        <p:spPr>
-          <a:xfrm>
-            <a:off x="640080" y="6035040"/>
-            <a:ext cx="5303520" cy="274320"/>
-          </a:xfrm>
-          <a:prstGeom prst="rect">
-            <a:avLst/>
-          </a:prstGeom>
-          <a:noFill/>
-          <a:ln/>
-        </p:spPr>
-        <p:txBody>
-          <a:bodyPr wrap="square" lIns="0" tIns="0" rIns="0" bIns="0" rtlCol="0" anchor="ctr">
-            <a:normAutofit/>
-          </a:bodyPr>
-          <a:lstStyle/>
-          <a:p>
-            <a:pPr algn="l" indent="0" marL="0">
-              <a:buNone/>
-            </a:pPr>
-            <a:r>
-              <a:rPr lang="en-US" sz="1300" b="1" dirty="0">
-                <a:solidFill>
                   <a:srgbClr val="F2C14E"/>
                 </a:solidFill>
                 <a:latin typeface="Calibri" pitchFamily="34" charset="0"/>
                 <a:ea typeface="Calibri" pitchFamily="34" charset="-122"/>
                 <a:cs typeface="Calibri" pitchFamily="34" charset="-120"/>
               </a:rPr>
-              <a:t>github.com/ghostkernel-core/cdm-pipeline</a:t>
+              <a:t>Result: rerunning the ETL recreates the same complete CDM package.</a:t>
             </a:r>
             <a:endParaRPr lang="en-US" sz="1300" dirty="0"/>
           </a:p>

</xml_diff>

<commit_message>
Show the full ETL lifecycle
</commit_message>
<xml_diff>
--- a/docs/CDM-pipeline-technical-walkthrough.pptx
+++ b/docs/CDM-pipeline-technical-walkthrough.pptx
@@ -505,7 +505,7 @@
           <a:p>
             <a:r>
               <a:rPr lang="en-US" dirty="0"/>
-              <a:t>Open with the ETL result. Python reads the two supplied CSV files, cleans and validates Contact and SalesOrder, writes the entity and quarantine CSVs, and generates model.json. It writes five contacts and four valid orders, quarantines the orphan order, and serializes timestamps in exact UTC ISO 8601 format.</a:t>
+              <a:t>Open with the complete ETL path. Python parses the two supplied CSV files, transforms source fields into Contact and SalesOrder, validates each model and the foreign-key relationship, then loads clean entity files, rejected rows, logs and model.json. The result is five contacts, four valid orders, one quarantined order and exact UTC ISO 8601 timestamps.</a:t>
             </a:r>
             <a:endParaRPr lang="en-US" dirty="0"/>
           </a:p>
@@ -593,7 +593,7 @@
           <a:p>
             <a:r>
               <a:rPr lang="en-US" dirty="0"/>
-              <a:t>Use John Smith as the running example: uppercase email becomes lowercase and the no-zone timestamp is treated as UTC. The reader also repairs CST-005 when it is split over two lines. Pydantic validates each entity. The same model definitions control the CSV column order and model.json attributes, preventing drift.</a:t>
+              <a:t>Walk left to right through the program. csv.reader parses each source file and the customer reader repairs CST-005 when it is split over two physical lines. Cleaning functions split the name, normalize or clear the email, convert the timestamp to UTC and map the status. The transformed values are passed into the Pydantic Contact model before write_entity loads the validated row. The same model definitions later control CSV columns and model.json attributes.</a:t>
             </a:r>
             <a:endParaRPr lang="en-US" dirty="0"/>
           </a:p>
@@ -1510,7 +1510,7 @@
                 <a:ea typeface="Calibri" pitchFamily="34" charset="-122"/>
                 <a:cs typeface="Calibri" pitchFamily="34" charset="-120"/>
               </a:rPr>
-              <a:t>Python reads, cleans, validates and writes the complete CDM package.</a:t>
+              <a:t>Python parses, transforms, validates and loads the complete CDM package.</a:t>
             </a:r>
             <a:endParaRPr lang="en-US" sz="1800" dirty="0"/>
           </a:p>
@@ -2295,7 +2295,7 @@
                 <a:ea typeface="Calibri" pitchFamily="34" charset="-122"/>
                 <a:cs typeface="Calibri" pitchFamily="34" charset="-120"/>
               </a:rPr>
-              <a:t>read raw records</a:t>
+              <a:t>PARSE raw rows</a:t>
             </a:r>
             <a:endParaRPr lang="en-US" sz="1200" dirty="0"/>
           </a:p>
@@ -2402,7 +2402,7 @@
                 <a:ea typeface="Calibri" pitchFamily="34" charset="-122"/>
                 <a:cs typeface="Calibri" pitchFamily="34" charset="-120"/>
               </a:rPr>
-              <a:t>clean + validate</a:t>
+              <a:t>TRANSFORM fields</a:t>
             </a:r>
             <a:endParaRPr lang="en-US" sz="1200" dirty="0"/>
           </a:p>
@@ -2509,7 +2509,7 @@
                 <a:ea typeface="Calibri" pitchFamily="34" charset="-122"/>
                 <a:cs typeface="Calibri" pitchFamily="34" charset="-120"/>
               </a:rPr>
-              <a:t>write data + rejects</a:t>
+              <a:t>VALIDATE models + FK</a:t>
             </a:r>
             <a:endParaRPr lang="en-US" sz="1200" dirty="0"/>
           </a:p>
@@ -2616,7 +2616,7 @@
                 <a:ea typeface="Calibri" pitchFamily="34" charset="-122"/>
                 <a:cs typeface="Calibri" pitchFamily="34" charset="-120"/>
               </a:rPr>
-              <a:t>generate model.json</a:t>
+              <a:t>LOAD data + metadata</a:t>
             </a:r>
             <a:endParaRPr lang="en-US" sz="1200" dirty="0"/>
           </a:p>
@@ -2723,7 +2723,7 @@
                 <a:ea typeface="Cambria" pitchFamily="34" charset="-122"/>
                 <a:cs typeface="Cambria" pitchFamily="34" charset="-120"/>
               </a:rPr>
-              <a:t>One path from source row to CDM</a:t>
+              <a:t>Parse and transform each source row</a:t>
             </a:r>
             <a:endParaRPr lang="en-US" sz="3000" dirty="0"/>
           </a:p>
@@ -2764,7 +2764,7 @@
                 <a:ea typeface="Calibri" pitchFamily="34" charset="-122"/>
                 <a:cs typeface="Calibri" pitchFamily="34" charset="-120"/>
               </a:rPr>
-              <a:t>The target models drive validation, CSV columns and manifest attributes.</a:t>
+              <a:t>Cleaning rules turn irregular input into typed CDM fields.</a:t>
             </a:r>
             <a:endParaRPr lang="en-US" sz="1400" dirty="0"/>
           </a:p>
@@ -2900,7 +2900,7 @@
                 <a:ea typeface="Calibri" pitchFamily="34" charset="-122"/>
                 <a:cs typeface="Calibri" pitchFamily="34" charset="-120"/>
               </a:rPr>
-              <a:t>READ</a:t>
+              <a:t>PARSE</a:t>
             </a:r>
             <a:endParaRPr lang="en-US" sz="1400" dirty="0"/>
           </a:p>
@@ -2941,7 +2941,7 @@
                 <a:ea typeface="Calibri" pitchFamily="34" charset="-122"/>
                 <a:cs typeface="Calibri" pitchFamily="34" charset="-120"/>
               </a:rPr>
-              <a:t>repair split row</a:t>
+              <a:t>read + repair rows</a:t>
             </a:r>
             <a:endParaRPr lang="en-US" sz="1100" dirty="0"/>
           </a:p>
@@ -3101,7 +3101,7 @@
                 <a:ea typeface="Calibri" pitchFamily="34" charset="-122"/>
                 <a:cs typeface="Calibri" pitchFamily="34" charset="-120"/>
               </a:rPr>
-              <a:t>CLEAN + MODEL</a:t>
+              <a:t>TRANSFORM</a:t>
             </a:r>
             <a:endParaRPr lang="en-US" sz="1400" dirty="0"/>
           </a:p>
@@ -3142,7 +3142,7 @@
                 <a:ea typeface="Calibri" pitchFamily="34" charset="-122"/>
                 <a:cs typeface="Calibri" pitchFamily="34" charset="-120"/>
               </a:rPr>
-              <a:t>Pydantic validation</a:t>
+              <a:t>clean + map fields</a:t>
             </a:r>
             <a:endParaRPr lang="en-US" sz="1100" dirty="0"/>
           </a:p>
@@ -3302,7 +3302,7 @@
                 <a:ea typeface="Calibri" pitchFamily="34" charset="-122"/>
                 <a:cs typeface="Calibri" pitchFamily="34" charset="-120"/>
               </a:rPr>
-              <a:t>WRITE</a:t>
+              <a:t>VALIDATE</a:t>
             </a:r>
             <a:endParaRPr lang="en-US" sz="1400" dirty="0"/>
           </a:p>
@@ -3343,7 +3343,7 @@
                 <a:ea typeface="Calibri" pitchFamily="34" charset="-122"/>
                 <a:cs typeface="Calibri" pitchFamily="34" charset="-120"/>
               </a:rPr>
-              <a:t>data · quarantine · logs</a:t>
+              <a:t>Pydantic entity model</a:t>
             </a:r>
             <a:endParaRPr lang="en-US" sz="1100" dirty="0"/>
           </a:p>
@@ -3503,7 +3503,7 @@
                 <a:ea typeface="Calibri" pitchFamily="34" charset="-122"/>
                 <a:cs typeface="Calibri" pitchFamily="34" charset="-120"/>
               </a:rPr>
-              <a:t>DESCRIBE</a:t>
+              <a:t>LOAD</a:t>
             </a:r>
             <a:endParaRPr lang="en-US" sz="1400" dirty="0"/>
           </a:p>
@@ -3544,7 +3544,7 @@
                 <a:ea typeface="Calibri" pitchFamily="34" charset="-122"/>
                 <a:cs typeface="Calibri" pitchFamily="34" charset="-120"/>
               </a:rPr>
-              <a:t>generate model.json</a:t>
+              <a:t>write data + metadata</a:t>
             </a:r>
             <a:endParaRPr lang="en-US" sz="1100" dirty="0"/>
           </a:p>

</xml_diff>